<commit_message>
Add offline speed config, CLM5 phenology comparison and final ACM/KMS posters
- lm4: fast offline tables (no dry deposition, reduced diag + river_daily) as the
  phentest.sh default (-23 % wall time at 48 ranks, land output bit-identical),
  speed-test chain/timing/collect scripts, Codex performance review, notes 13.71
- poster: final ACM and KMS posters (pptx/pdf), KMS builder, four-region figures,
  phenology rule box (Weng et al. 2015), zonal-month bias with MODIS barren mask,
  species map obs vs model (six species), cue-skill analysis for SOS/EOS,
  CLM5 vs LM4+ vs GIMMS phenology, supervisor review PDF
- docs: paper 1 plan (autumn phenology, benchmarks, CLM6/CTSM comparison)
- references: Murray-Tortarolo 2013, Park & Jeong 2021, CTSM daylength rule

Co-Authored-By: Claude Opus 5.5 <noreply@anthropic.com>
Claude-Session: https://claude.ai/code/session_014xupTiGubEY15LnWszFrCt
</commit_message>
<xml_diff>
--- a/poster/2026_LM4p_LAI/poster_2026_ACM_draft.pptx
+++ b/poster/2026_LM4p_LAI/poster_2026_ACM_draft.pptx
@@ -1170,10 +1170,16 @@
                   <a:schemeClr val="tx2"/>
                 </a:solidFill>
               </a:rPr>
-              <a:t>Vegetation controls the land–atmosphere exchange of energy, water and carbon; a biased leaf area index (LAI) therefore feeds back on the coupled climate. Offline evaluation under observed forcing isolates the land model's own errors.</a:t>
-            </a:r>
-          </a:p>
-          <a:p/>
+              <a:t>Vegetation controls the land–atmosphere exchange of energy, water and carbon; a biased leaf area index (LAI) therefore feeds back on the coupled climate. Offline evaluations show that most land models keep leaves too long in autumn (Murray-Tortarolo et al., 2013); offline runs isolate the land model's own errors.</a:t>
+            </a:r>
+          </a:p>
+          <a:p>
+            <a:endParaRPr lang="en-US" sz="3000" b="0" dirty="0">
+              <a:solidFill>
+                <a:schemeClr val="tx2"/>
+              </a:solidFill>
+            </a:endParaRPr>
+          </a:p>
           <a:p>
             <a:pPr marL="0" indent="0">
               <a:buNone/>
@@ -1187,7 +1193,13 @@
               <a:t>Key question: Does offline LM4+ reproduce the magnitude and the phenology of global LAI, and what causes the mismatch?</a:t>
             </a:r>
           </a:p>
-          <a:p/>
+          <a:p>
+            <a:endParaRPr lang="en-US" sz="3000" b="1" dirty="0">
+              <a:solidFill>
+                <a:schemeClr val="tx2"/>
+              </a:solidFill>
+            </a:endParaRPr>
+          </a:p>
           <a:p>
             <a:pPr marL="0" indent="0">
               <a:buNone/>
@@ -1201,7 +1213,13 @@
               <a:t>Objective 1: Benchmark 1982–2010 LAI against GIMMS LAI4g (pattern, magnitude, seasonal cycle).</a:t>
             </a:r>
           </a:p>
-          <a:p/>
+          <a:p>
+            <a:endParaRPr lang="en-US" sz="3000" b="0" dirty="0">
+              <a:solidFill>
+                <a:schemeClr val="tx2"/>
+              </a:solidFill>
+            </a:endParaRPr>
+          </a:p>
           <a:p>
             <a:pPr marL="0" indent="0">
               <a:buNone/>
@@ -2278,7 +2296,7 @@
                 </a:tc>
                 <a:extLst>
                   <a:ext uri="{0D108BD9-81ED-4DB2-BD59-A6C34878D82A}">
-                    <a16:rowId xmlns:a16="http://schemas.microsoft.com/office/drawing/2014/main" val="10003"/>
+                    <a16:rowId xmlns:a16="http://schemas.microsoft.com/office/drawing/2014/main" val="1632780710"/>
                   </a:ext>
                 </a:extLst>
               </a:tr>
@@ -2316,7 +2334,7 @@
                   <a:schemeClr val="tx2"/>
                 </a:solidFill>
               </a:rPr>
-              <a:t>Evaluation: 1982–2010 monthly climatology on a common 1° grid; MJJAS mean and bias; seasonal cycles in six IPCC AR6 regions. SOS/EOS = dates at which the interpolated monthly cycle crosses 50 % of its amplitude.</a:t>
+              <a:t>Evaluation: 1982–2010 monthly climatology on a common 1° grid; MJJAS mean and bias; seasonal cycles in four IPCC AR6 regions. SOS/EOS = dates at which the interpolated monthly cycle crosses 50 % of its amplitude (White et al., 1997).</a:t>
             </a:r>
             <a:endParaRPr lang="en-US" sz="3000" dirty="0"/>
           </a:p>
@@ -2470,7 +2488,7 @@
               <a:buChar char="•"/>
             </a:pPr>
             <a:r>
-              <a:rPr lang="en-US" sz="3000" dirty="0" b="0">
+              <a:rPr lang="en-US" sz="3000" b="0" dirty="0">
                 <a:solidFill>
                   <a:schemeClr val="tx1"/>
                 </a:solidFill>
@@ -2488,7 +2506,7 @@
               <a:buChar char="•"/>
             </a:pPr>
             <a:r>
-              <a:rPr lang="en-US" sz="3000" dirty="0" b="0">
+              <a:rPr lang="en-US" sz="3000" b="0" dirty="0">
                 <a:solidFill>
                   <a:schemeClr val="tx1"/>
                 </a:solidFill>
@@ -2505,7 +2523,7 @@
               <a:buChar char="•"/>
             </a:pPr>
             <a:r>
-              <a:rPr lang="en-US" sz="3000" dirty="0" b="1">
+              <a:rPr lang="en-US" sz="3000" b="1" dirty="0">
                 <a:solidFill>
                   <a:schemeClr val="tx1"/>
                 </a:solidFill>
@@ -2579,7 +2597,7 @@
                   <a:schemeClr val="bg1"/>
                 </a:solidFill>
               </a:rPr>
-              <a:t>RESULTS 2: SEASONAL TIMING AND ITS CAUSE</a:t>
+              <a:t>RESULTS 2: PHENOLOGY (OBS. AND MODEL)</a:t>
             </a:r>
             <a:endParaRPr lang="en-US" sz="4800" dirty="0"/>
           </a:p>
@@ -2593,7 +2611,7 @@
         </p:nvSpPr>
         <p:spPr>
           <a:xfrm>
-            <a:off x="16565760" y="18000406"/>
+            <a:off x="16565760" y="19741896"/>
             <a:ext cx="14919840" cy="1280160"/>
           </a:xfrm>
           <a:prstGeom prst="rect">
@@ -2615,7 +2633,7 @@
                   <a:schemeClr val="tx2"/>
                 </a:solidFill>
               </a:rPr>
-              <a:t>Figure 2. Climatological LAI seasonal cycle, 1982–2010, GIMMS vs LM4+ in six AR6 regions; markers: SOS/EOS at 50 % of the amplitude.</a:t>
+              <a:t>Figure 2. Climatological LAI seasonal cycle, 1982–2010, GIMMS vs LM4+ in four AR6 regions (shading: ±1 s.d. over 29 years); dotted / dashed lines: SOS / EOS at 50 % of the amplitude.</a:t>
             </a:r>
             <a:endParaRPr lang="en-US" sz="2600" dirty="0"/>
           </a:p>
@@ -2629,7 +2647,7 @@
         </p:nvSpPr>
         <p:spPr>
           <a:xfrm>
-            <a:off x="16565760" y="19372006"/>
+            <a:off x="16565760" y="21113496"/>
             <a:ext cx="14919840" cy="4206240"/>
           </a:xfrm>
           <a:prstGeom prst="rect">
@@ -2650,12 +2668,12 @@
               <a:buChar char="•"/>
             </a:pPr>
             <a:r>
-              <a:rPr lang="en-US" sz="3000" dirty="0" b="1">
+              <a:rPr lang="en-US" sz="3000" b="1" dirty="0">
                 <a:solidFill>
                   <a:schemeClr val="tx1"/>
                 </a:solidFill>
               </a:rPr>
-              <a:t>Leaf-off (EOS) is 28–70 days too late in every region (NWN +33, ESB +38, RFE +28, ENA +42, WCE +49, EAS +70 d); boreal leaf-on is also late (+13–24 d).</a:t>
+              <a:t>Leaf-off (EOS) is 27–38 days too late in every region (NEU +27, RFE +28, NWN +33, ESB +38 d) and in all 29 years; leaf-on is also late (+13–27 d).</a:t>
             </a:r>
             <a:endParaRPr lang="en-US" sz="3000" dirty="0"/>
           </a:p>
@@ -2668,7 +2686,7 @@
               <a:buChar char="•"/>
             </a:pPr>
             <a:r>
-              <a:rPr lang="en-US" sz="3000" dirty="0" b="0">
+              <a:rPr lang="en-US" sz="3000" b="0" dirty="0">
                 <a:solidFill>
                   <a:schemeClr val="tx1"/>
                 </a:solidFill>
@@ -2685,12 +2703,12 @@
               <a:buChar char="•"/>
             </a:pPr>
             <a:r>
-              <a:rPr lang="en-US" sz="3000" dirty="0" b="0">
+              <a:rPr lang="en-US" sz="3000" b="0" dirty="0">
                 <a:solidFill>
                   <a:schemeClr val="tx1"/>
                 </a:solidFill>
               </a:rPr>
-              <a:t>The observed EOS instead clusters at a day length of 11.4–13.3 h regardless of temperature: a day-length cue is missing.</a:t>
+              <a:t>The observed EOS falls at a day length of 12.7–13.3 h in NWN, ESB and RFE: a day-length cue is missing in the model.</a:t>
             </a:r>
           </a:p>
         </p:txBody>
@@ -2703,7 +2721,7 @@
         </p:nvSpPr>
         <p:spPr>
           <a:xfrm>
-            <a:off x="16565760" y="23761126"/>
+            <a:off x="16565760" y="29696386"/>
             <a:ext cx="14919840" cy="1143000"/>
           </a:xfrm>
           <a:prstGeom prst="roundRect">
@@ -2737,7 +2755,7 @@
         </p:nvSpPr>
         <p:spPr>
           <a:xfrm>
-            <a:off x="16565760" y="23761126"/>
+            <a:off x="16565760" y="29696386"/>
             <a:ext cx="14919840" cy="1143000"/>
           </a:xfrm>
           <a:prstGeom prst="rect">
@@ -2754,12 +2772,12 @@
               <a:buNone/>
             </a:pPr>
             <a:r>
-              <a:rPr lang="en-US" sz="4800" b="1" dirty="0">
+              <a:rPr lang="en-US" sz="4000" b="1" dirty="0">
                 <a:solidFill>
                   <a:schemeClr val="bg1"/>
                 </a:solidFill>
               </a:rPr>
-              <a:t>RESULTS 3: DAY-LENGTH LEAF-OFF PILOT RUNS</a:t>
+              <a:t>RESULTS 3: MODIFIED PHENOLOGY RULES (PILOT)</a:t>
             </a:r>
             <a:endParaRPr lang="en-US" sz="4800" dirty="0"/>
           </a:p>
@@ -2773,8 +2791,8 @@
         </p:nvSpPr>
         <p:spPr>
           <a:xfrm>
-            <a:off x="16550640" y="32754692"/>
-            <a:ext cx="14904720" cy="4572000"/>
+            <a:off x="25146000" y="31067986"/>
+            <a:ext cx="6309360" cy="5768558"/>
           </a:xfrm>
           <a:prstGeom prst="rect">
             <a:avLst/>
@@ -2790,12 +2808,12 @@
               <a:buNone/>
             </a:pPr>
             <a:r>
-              <a:rPr lang="en-US" sz="3000" b="0" dirty="0">
+              <a:rPr lang="en-US" sz="2400" b="0" dirty="0">
                 <a:solidFill>
                   <a:schemeClr val="tx2"/>
                 </a:solidFill>
               </a:rPr>
-              <a:t>Temperature threshold alone (TC10): the autumn drop moves little and spring leaf-on is delayed as a side effect.</a:t>
+              <a:t>TC10 (temperature only): autumn drop moves, but spring leaf-on is delayed.</a:t>
             </a:r>
             <a:endParaRPr lang="en-US" sz="3000" dirty="0"/>
           </a:p>
@@ -2804,12 +2822,12 @@
               <a:buNone/>
             </a:pPr>
             <a:r>
-              <a:rPr lang="en-US" sz="3000" b="1" dirty="0">
+              <a:rPr lang="en-US" sz="2400" b="1" dirty="0">
                 <a:solidFill>
                   <a:schemeClr val="tx2"/>
                 </a:solidFill>
               </a:rPr>
-              <a:t>DL14+TC10 removes 20–50 % of the Sep–Oct excess in boreal regions (NWN 38 %, ESB 20 %, RFE 50 %); the 50–70°N EOS bias falls from +33 to +16 d with spring unchanged.</a:t>
+              <a:t>DL14+TC10 removes the Sep–Oct excess by NEU 65 %, RFE 50 %, NWN 38 %, ESB 20 %, with spring unchanged.</a:t>
             </a:r>
           </a:p>
           <a:p>
@@ -2817,12 +2835,12 @@
               <a:buNone/>
             </a:pPr>
             <a:r>
-              <a:rPr lang="en-US" sz="3000" b="0" dirty="0">
+              <a:rPr lang="en-US" sz="2400" b="1" dirty="0">
                 <a:solidFill>
                   <a:schemeClr val="tx2"/>
                 </a:solidFill>
               </a:rPr>
-              <a:t>Temperate regions are unchanged: the rule was applied only to larch and C3 grass; broadleaf trees need a ≈11.5 h cue.</a:t>
+              <a:t>50–70°N EOS bias: +33 → +16 d.</a:t>
             </a:r>
           </a:p>
           <a:p>
@@ -2830,12 +2848,12 @@
               <a:buNone/>
             </a:pPr>
             <a:r>
-              <a:rPr lang="en-US" sz="3000" b="0" dirty="0">
+              <a:rPr lang="en-US" sz="2400" b="0" dirty="0">
                 <a:solidFill>
                   <a:schemeClr val="tx2"/>
                 </a:solidFill>
               </a:rPr>
-              <a:t>Even the small TC10 shift changes Sep–Oct fluxes at 50–70°N: ET −4.5 %, GPP −11 %, runoff +4.7 %.</a:t>
+              <a:t>Sep–Oct fluxes change too (50–70°N, TC10): ET −4.5 %, GPP −11 %.</a:t>
             </a:r>
           </a:p>
         </p:txBody>
@@ -2848,7 +2866,7 @@
         </p:nvSpPr>
         <p:spPr>
           <a:xfrm>
-            <a:off x="16565760" y="31383092"/>
+            <a:off x="16565760" y="36927984"/>
             <a:ext cx="14919840" cy="1280160"/>
           </a:xfrm>
           <a:prstGeom prst="rect">
@@ -2870,7 +2888,7 @@
                   <a:schemeClr val="tx2"/>
                 </a:solidFill>
               </a:rPr>
-              <a:t>Figure 3. Normalized 2010 LAI cycle, (LAI − min)/(max − min), in six regions: GIMMS, CTRL, TC10 and DL14+TC10.</a:t>
+              <a:t>Figure 3. Normalized 2010 LAI cycle, (LAI − min)/(max − min), in the four regions with the largest gain: GIMMS, CTRL, TC10 and DL14+TC10.</a:t>
             </a:r>
             <a:endParaRPr lang="en-US" sz="2600" dirty="0"/>
           </a:p>
@@ -2884,7 +2902,7 @@
         </p:nvSpPr>
         <p:spPr>
           <a:xfrm>
-            <a:off x="16565760" y="37509572"/>
+            <a:off x="16565760" y="38299584"/>
             <a:ext cx="14919840" cy="1143000"/>
           </a:xfrm>
           <a:prstGeom prst="roundRect">
@@ -2918,7 +2936,7 @@
         </p:nvSpPr>
         <p:spPr>
           <a:xfrm>
-            <a:off x="16565760" y="37509572"/>
+            <a:off x="16565760" y="38299584"/>
             <a:ext cx="14919840" cy="1143000"/>
           </a:xfrm>
           <a:prstGeom prst="rect">
@@ -2954,7 +2972,7 @@
         </p:nvSpPr>
         <p:spPr>
           <a:xfrm>
-            <a:off x="16565760" y="38881172"/>
+            <a:off x="16565760" y="39671184"/>
             <a:ext cx="14919840" cy="5120640"/>
           </a:xfrm>
           <a:prstGeom prst="rect">
@@ -3006,7 +3024,7 @@
                   <a:schemeClr val="tx2"/>
                 </a:solidFill>
               </a:rPr>
-              <a:t>A day-length leaf-off rule removes about half of the boreal EOS bias with no spring side effect; type-specific thresholds (larch 13.5 h, C3 grass 12.5 h, broadleaf 11.5 h) are being tested.</a:t>
+              <a:t>A day-length leaf-off rule removes about half of the boreal EOS bias with no spring side effect; further threshold tests are under way.</a:t>
             </a:r>
           </a:p>
           <a:p>
@@ -3033,7 +3051,7 @@
         </p:nvSpPr>
         <p:spPr>
           <a:xfrm>
-            <a:off x="16565760" y="44696756"/>
+            <a:off x="16565760" y="45486768"/>
             <a:ext cx="14919840" cy="1143000"/>
           </a:xfrm>
           <a:prstGeom prst="roundRect">
@@ -3067,7 +3085,7 @@
         </p:nvSpPr>
         <p:spPr>
           <a:xfrm>
-            <a:off x="16565760" y="44696756"/>
+            <a:off x="16565760" y="45486768"/>
             <a:ext cx="14919840" cy="1143000"/>
           </a:xfrm>
           <a:prstGeom prst="rect">
@@ -3103,7 +3121,7 @@
         </p:nvSpPr>
         <p:spPr>
           <a:xfrm>
-            <a:off x="16565760" y="45976916"/>
+            <a:off x="16565760" y="46766928"/>
             <a:ext cx="14919840" cy="3099816"/>
           </a:xfrm>
           <a:prstGeom prst="rect">
@@ -3123,12 +3141,12 @@
               <a:buNone/>
             </a:pPr>
             <a:r>
-              <a:rPr lang="en-US" sz="2000" dirty="0" b="0">
+              <a:rPr lang="en-US" sz="2000" b="0" dirty="0">
                 <a:solidFill>
                   <a:schemeClr val="tx1"/>
                 </a:solidFill>
               </a:rPr>
-              <a:t>Cao, S., et al. (2023). ESSD, 15, 4877. • Cucchi, M., et al. (2020). ESSD, 12, 2097. • Shevliakova, E., et al. (2024). JAMES, 16. • Weng, E., et al. (2015). Biogeosciences, 12, 2655. • Iturbide, M., et al. (2020). ESSD, 12, 2959. • Zohner, C. M., et al. (2023). Science, 381, eadf5098.</a:t>
+              <a:t>Cao, S., et al. (2023). ESSD, 15, 4877. • Cucchi, M., et al. (2020). ESSD, 12, 2097. • Shevliakova, E., et al. (2024). JAMES, 16. • Weng, E., et al. (2015). Biogeosciences, 12, 2655. • Iturbide, M., et al. (2020). ESSD, 12, 2959. • Zohner, C. M., et al. (2023). Science, 381, eadf5098. • White, M. A., et al. (1997). GBC, 11, 217. • Murray-Tortarolo, G., et al. (2013). Remote Sens., 5, 4819.</a:t>
             </a:r>
             <a:endParaRPr lang="en-US" sz="2400" dirty="0"/>
           </a:p>
@@ -3140,7 +3158,7 @@
               <a:buNone/>
             </a:pPr>
             <a:r>
-              <a:rPr lang="en-US" sz="2000" dirty="0" b="1">
+              <a:rPr lang="en-US" sz="2000" b="1" dirty="0">
                 <a:solidFill>
                   <a:schemeClr val="tx1"/>
                 </a:solidFill>
@@ -3440,8 +3458,8 @@
         </p:blipFill>
         <p:spPr>
           <a:xfrm>
-            <a:off x="17373600" y="11704320"/>
-            <a:ext cx="13258800" cy="6158926"/>
+            <a:off x="18242280" y="11704320"/>
+            <a:ext cx="11521440" cy="7900416"/>
           </a:xfrm>
           <a:prstGeom prst="rect">
             <a:avLst/>
@@ -3450,7 +3468,7 @@
       </p:pic>
       <p:pic>
         <p:nvPicPr>
-          <p:cNvPr id="56" name="Picture fig3b_phentest_regions_normalised_dl.png" descr="fig3b_phentest_regions_normalised_dl.png"/>
+          <p:cNvPr id="56" name="Picture phenology rule box" descr="box_phenology_rule.png"/>
           <p:cNvPicPr>
             <a:picLocks noChangeAspect="1"/>
           </p:cNvPicPr>
@@ -3458,20 +3476,149 @@
         </p:nvPicPr>
         <p:blipFill>
           <a:blip r:embed="rId7"/>
+          <a:srcRect l="1441" t="5005" r="5696" b="4032"/>
           <a:stretch>
             <a:fillRect/>
           </a:stretch>
         </p:blipFill>
         <p:spPr>
           <a:xfrm>
-            <a:off x="17373600" y="25132726"/>
-            <a:ext cx="13258800" cy="6158926"/>
+            <a:off x="17655362" y="25111546"/>
+            <a:ext cx="12695275" cy="3761880"/>
           </a:xfrm>
           <a:prstGeom prst="rect">
             <a:avLst/>
           </a:prstGeom>
         </p:spPr>
       </p:pic>
+      <p:pic>
+        <p:nvPicPr>
+          <p:cNvPr id="57" name="Picture fig3b_phentest_regions_normalised_NEU_RFE_NWN_ESB_poster.png" descr="fig3b_phentest_regions_normalised_NEU_RFE_NWN_ESB_poster.png"/>
+          <p:cNvPicPr>
+            <a:picLocks noChangeAspect="1"/>
+          </p:cNvPicPr>
+          <p:nvPr/>
+        </p:nvPicPr>
+        <p:blipFill>
+          <a:blip r:embed="rId8"/>
+          <a:stretch>
+            <a:fillRect/>
+          </a:stretch>
+        </p:blipFill>
+        <p:spPr>
+          <a:xfrm>
+            <a:off x="16550640" y="31067986"/>
+            <a:ext cx="8412480" cy="5768558"/>
+          </a:xfrm>
+          <a:prstGeom prst="rect">
+            <a:avLst/>
+          </a:prstGeom>
+        </p:spPr>
+      </p:pic>
+      <p:sp>
+        <p:nvSpPr>
+          <p:cNvPr id="24" name="타원 23">
+            <a:extLst>
+              <a:ext uri="{FF2B5EF4-FFF2-40B4-BE49-F238E27FC236}">
+                <a16:creationId xmlns:a16="http://schemas.microsoft.com/office/drawing/2014/main" id="{895484FD-49D2-2D07-CD82-0A8FD8968BD0}"/>
+              </a:ext>
+            </a:extLst>
+          </p:cNvPr>
+          <p:cNvSpPr/>
+          <p:nvPr/>
+        </p:nvSpPr>
+        <p:spPr>
+          <a:xfrm>
+            <a:off x="19613880" y="31821120"/>
+            <a:ext cx="685800" cy="685800"/>
+          </a:xfrm>
+          <a:prstGeom prst="ellipse">
+            <a:avLst/>
+          </a:prstGeom>
+          <a:noFill/>
+          <a:ln w="22225">
+            <a:solidFill>
+              <a:srgbClr val="FF0000"/>
+            </a:solidFill>
+          </a:ln>
+        </p:spPr>
+        <p:style>
+          <a:lnRef idx="2">
+            <a:schemeClr val="accent1">
+              <a:shade val="15000"/>
+            </a:schemeClr>
+          </a:lnRef>
+          <a:fillRef idx="1">
+            <a:schemeClr val="accent1"/>
+          </a:fillRef>
+          <a:effectRef idx="0">
+            <a:schemeClr val="accent1"/>
+          </a:effectRef>
+          <a:fontRef idx="minor">
+            <a:schemeClr val="lt1"/>
+          </a:fontRef>
+        </p:style>
+        <p:txBody>
+          <a:bodyPr rtlCol="0" anchor="ctr"/>
+          <a:lstStyle/>
+          <a:p>
+            <a:pPr algn="ctr"/>
+            <a:endParaRPr kumimoji="1" lang="ko-KR" altLang="en-US"/>
+          </a:p>
+        </p:txBody>
+      </p:sp>
+      <p:sp>
+        <p:nvSpPr>
+          <p:cNvPr id="25" name="타원 24">
+            <a:extLst>
+              <a:ext uri="{FF2B5EF4-FFF2-40B4-BE49-F238E27FC236}">
+                <a16:creationId xmlns:a16="http://schemas.microsoft.com/office/drawing/2014/main" id="{B959D5F5-884F-19A5-26F9-9CCD15BCAF07}"/>
+              </a:ext>
+            </a:extLst>
+          </p:cNvPr>
+          <p:cNvSpPr/>
+          <p:nvPr/>
+        </p:nvSpPr>
+        <p:spPr>
+          <a:xfrm>
+            <a:off x="18379440" y="32164020"/>
+            <a:ext cx="685800" cy="685800"/>
+          </a:xfrm>
+          <a:prstGeom prst="ellipse">
+            <a:avLst/>
+          </a:prstGeom>
+          <a:noFill/>
+          <a:ln w="22225">
+            <a:solidFill>
+              <a:srgbClr val="FF0000"/>
+            </a:solidFill>
+          </a:ln>
+        </p:spPr>
+        <p:style>
+          <a:lnRef idx="2">
+            <a:schemeClr val="accent1">
+              <a:shade val="15000"/>
+            </a:schemeClr>
+          </a:lnRef>
+          <a:fillRef idx="1">
+            <a:schemeClr val="accent1"/>
+          </a:fillRef>
+          <a:effectRef idx="0">
+            <a:schemeClr val="accent1"/>
+          </a:effectRef>
+          <a:fontRef idx="minor">
+            <a:schemeClr val="lt1"/>
+          </a:fontRef>
+        </p:style>
+        <p:txBody>
+          <a:bodyPr rtlCol="0" anchor="ctr"/>
+          <a:lstStyle/>
+          <a:p>
+            <a:pPr algn="ctr"/>
+            <a:endParaRPr kumimoji="1" lang="ko-KR" altLang="en-US"/>
+          </a:p>
+        </p:txBody>
+      </p:sp>
     </p:spTree>
   </p:cSld>
   <p:clrMapOvr>

</xml_diff>